<commit_message>
Reframe as scenarios (nothing decided); add Cost-of-2nd-Source matrix
- Model: soften 'decided' labels to scenario language; add 'Cost of 2nd Source'
  tab — annual redundancy premium across allocation x 2nd-source price x SNP
  surcharge (incl. SNP-raises-price cases)
- Report & slides: replace decided-plan framing with scenario cost analysis;
  add the cost matrix and the 'SNP increase hits retained volume' insight

Co-Authored-By: Claude Opus 4.8 <noreply@anthropic.com>
Claude-Session: https://claude.ai/code/session_01LkE2ZRYs3PLyj8XHTsU3i4
</commit_message>
<xml_diff>
--- a/PVA second supplier initiative/PVA_Second_Source_Slides.pptx
+++ b/PVA second supplier initiative/PVA_Second_Source_Slides.pptx
@@ -3290,7 +3290,7 @@
                 </a:solidFill>
                 <a:latin typeface="Calibri"/>
               </a:rPr>
-              <a:t>Oscar Penny  |  2026-06-27  |  In Progress — front-runner identified (CJB); APV in competition</a:t>
+              <a:t>Oscar Penny  |  2026-06-27  |  In Progress — CJB &amp; APV engaged; this deck shows the COST of a second source across scenarios (nothing decided)</a:t>
             </a:r>
           </a:p>
         </p:txBody>
@@ -3409,7 +3409,7 @@
         </p:nvSpPr>
         <p:spPr>
           <a:xfrm>
-            <a:off x="731520" y="1463040"/>
+            <a:off x="731520" y="1280160"/>
             <a:ext cx="10698480" cy="1280160"/>
           </a:xfrm>
           <a:prstGeom prst="rect">
@@ -3429,13 +3429,13 @@
               </a:spcAft>
             </a:pPr>
             <a:r>
-              <a:rPr sz="3400" b="1" i="0">
+              <a:rPr sz="3200" b="1" i="0">
                 <a:solidFill>
                   <a:srgbClr val="FFFFFF"/>
                 </a:solidFill>
                 <a:latin typeface="Calibri"/>
               </a:rPr>
-              <a:t>Recommendation</a:t>
+              <a:t>What a Second Source Costs — Summary</a:t>
             </a:r>
           </a:p>
         </p:txBody>
@@ -3448,8 +3448,8 @@
         </p:nvSpPr>
         <p:spPr>
           <a:xfrm>
-            <a:off x="731520" y="3017520"/>
-            <a:ext cx="10698480" cy="3291840"/>
+            <a:off x="731520" y="2926080"/>
+            <a:ext cx="10698480" cy="3474720"/>
           </a:xfrm>
           <a:prstGeom prst="rect">
             <a:avLst/>
@@ -3464,65 +3464,65 @@
           <a:p>
             <a:pPr algn="l">
               <a:spcAft>
-                <a:spcPts val="1200"/>
-              </a:spcAft>
-            </a:pPr>
-            <a:r>
-              <a:rPr sz="1700" b="0" i="0">
+                <a:spcPts val="1400"/>
+              </a:spcAft>
+            </a:pPr>
+            <a:r>
+              <a:rPr sz="1600" b="0" i="0">
                 <a:solidFill>
                   <a:srgbClr val="FFFFFF"/>
                 </a:solidFill>
                 <a:latin typeface="Calibri"/>
               </a:rPr>
-              <a:t>•  Advance CJB as front-runner — hard gate cleared, ideal small-batch fit, fast lead time.</a:t>
+              <a:t>•  If SNP holds price: redundancy is modest — ~$5–13k/yr depending on split &amp; 2nd-source premium (≈$0 at parity).</a:t>
             </a:r>
           </a:p>
           <a:p>
             <a:pPr algn="l">
               <a:spcAft>
-                <a:spcPts val="1200"/>
-              </a:spcAft>
-            </a:pPr>
-            <a:r>
-              <a:rPr sz="1700" b="0" i="0">
+                <a:spcPts val="1400"/>
+              </a:spcAft>
+            </a:pPr>
+            <a:r>
+              <a:rPr sz="1600" b="0" i="0">
                 <a:solidFill>
                   <a:srgbClr val="FFFFFF"/>
                 </a:solidFill>
                 <a:latin typeface="Calibri"/>
               </a:rPr>
-              <a:t>•  Keep APV in active competition — capable, interested, and our pricing leverage.</a:t>
+              <a:t>•  If SNP raises price on the reduced volume: cost can roughly double — that surcharge, on the larger retained volume, is often the bigger driver.</a:t>
             </a:r>
           </a:p>
           <a:p>
             <a:pPr algn="l">
               <a:spcAft>
-                <a:spcPts val="1200"/>
-              </a:spcAft>
-            </a:pPr>
-            <a:r>
-              <a:rPr sz="1700" b="0" i="0">
+                <a:spcPts val="1400"/>
+              </a:spcAft>
+            </a:pPr>
+            <a:r>
+              <a:rPr sz="1600" b="0" i="0">
                 <a:solidFill>
                   <a:srgbClr val="FFFFFF"/>
                 </a:solidFill>
                 <a:latin typeface="Calibri"/>
               </a:rPr>
-              <a:t>•  Award the second source ~1 drum/week (~35%) at a ~$8.8k/yr redundancy premium.</a:t>
+              <a:t>•  Range across plausible scenarios: ~$2.5k to ~$30k/yr.</a:t>
             </a:r>
           </a:p>
           <a:p>
             <a:pPr algn="l">
               <a:spcAft>
-                <a:spcPts val="1200"/>
-              </a:spcAft>
-            </a:pPr>
-            <a:r>
-              <a:rPr sz="1700" b="0" i="0">
+                <a:spcPts val="1400"/>
+              </a:spcAft>
+            </a:pPr>
+            <a:r>
+              <a:rPr sz="1600" b="0" i="0">
                 <a:solidFill>
                   <a:srgbClr val="FFFFFF"/>
                 </a:solidFill>
                 <a:latin typeface="Calibri"/>
               </a:rPr>
-              <a:t>•  Unblock the two gating items: SNP CoA viscosity target, and the CJB NDA.</a:t>
+              <a:t>•  Nothing decided — CJB &amp; APV both viable; scenarios stay ready to update as quotes (and any SNP re-price) arrive.</a:t>
             </a:r>
           </a:p>
         </p:txBody>
@@ -4494,7 +4494,7 @@
                 </a:solidFill>
                 <a:latin typeface="Calibri"/>
               </a:rPr>
-              <a:t>Demand &amp; Economics</a:t>
+              <a:t>The Cost of Keeping a Second Source</a:t>
             </a:r>
           </a:p>
         </p:txBody>
@@ -4546,8 +4546,8 @@
         </p:nvSpPr>
         <p:spPr>
           <a:xfrm>
-            <a:off x="548640" y="1188720"/>
-            <a:ext cx="2651760" cy="1645920"/>
+            <a:off x="548640" y="1143000"/>
+            <a:ext cx="2651760" cy="1371600"/>
           </a:xfrm>
           <a:prstGeom prst="rect">
             <a:avLst/>
@@ -4590,8 +4590,8 @@
         </p:nvSpPr>
         <p:spPr>
           <a:xfrm>
-            <a:off x="640080" y="1325880"/>
-            <a:ext cx="2468879" cy="1371600"/>
+            <a:off x="640080" y="1280160"/>
+            <a:ext cx="2468879" cy="1097280"/>
           </a:xfrm>
           <a:prstGeom prst="rect">
             <a:avLst/>
@@ -4645,8 +4645,8 @@
         </p:nvSpPr>
         <p:spPr>
           <a:xfrm>
-            <a:off x="3383280" y="1188720"/>
-            <a:ext cx="2651760" cy="1645920"/>
+            <a:off x="3383280" y="1143000"/>
+            <a:ext cx="2651760" cy="1371600"/>
           </a:xfrm>
           <a:prstGeom prst="rect">
             <a:avLst/>
@@ -4689,8 +4689,8 @@
         </p:nvSpPr>
         <p:spPr>
           <a:xfrm>
-            <a:off x="3474720" y="1325880"/>
-            <a:ext cx="2468879" cy="1371600"/>
+            <a:off x="3474720" y="1280160"/>
+            <a:ext cx="2468879" cy="1097280"/>
           </a:xfrm>
           <a:prstGeom prst="rect">
             <a:avLst/>
@@ -4744,8 +4744,8 @@
         </p:nvSpPr>
         <p:spPr>
           <a:xfrm>
-            <a:off x="6217920" y="1188720"/>
-            <a:ext cx="2651760" cy="1645920"/>
+            <a:off x="6217920" y="1143000"/>
+            <a:ext cx="2651760" cy="1371600"/>
           </a:xfrm>
           <a:prstGeom prst="rect">
             <a:avLst/>
@@ -4788,8 +4788,8 @@
         </p:nvSpPr>
         <p:spPr>
           <a:xfrm>
-            <a:off x="6309359" y="1325880"/>
-            <a:ext cx="2468879" cy="1371600"/>
+            <a:off x="6309359" y="1280160"/>
+            <a:ext cx="2468879" cy="1097280"/>
           </a:xfrm>
           <a:prstGeom prst="rect">
             <a:avLst/>
@@ -4843,8 +4843,8 @@
         </p:nvSpPr>
         <p:spPr>
           <a:xfrm>
-            <a:off x="9052560" y="1188720"/>
-            <a:ext cx="2560320" cy="1645920"/>
+            <a:off x="9052560" y="1143000"/>
+            <a:ext cx="2560320" cy="1371600"/>
           </a:xfrm>
           <a:prstGeom prst="rect">
             <a:avLst/>
@@ -4887,8 +4887,8 @@
         </p:nvSpPr>
         <p:spPr>
           <a:xfrm>
-            <a:off x="9144000" y="1325880"/>
-            <a:ext cx="2377439" cy="1371600"/>
+            <a:off x="9144000" y="1280160"/>
+            <a:ext cx="2377439" cy="1097280"/>
           </a:xfrm>
           <a:prstGeom prst="rect">
             <a:avLst/>
@@ -4929,65 +4929,21 @@
                 </a:solidFill>
                 <a:latin typeface="Calibri"/>
               </a:rPr>
-              <a:t>SNP price ($337.50/drum)</a:t>
-            </a:r>
-          </a:p>
-        </p:txBody>
-      </p:sp>
-      <p:sp>
-        <p:nvSpPr>
-          <p:cNvPr id="13" name="Rectangle 12"/>
-          <p:cNvSpPr/>
-          <p:nvPr/>
-        </p:nvSpPr>
-        <p:spPr>
-          <a:xfrm>
-            <a:off x="548640" y="3108960"/>
-            <a:ext cx="11064240" cy="457200"/>
-          </a:xfrm>
-          <a:prstGeom prst="rect">
-            <a:avLst/>
-          </a:prstGeom>
-          <a:solidFill>
-            <a:srgbClr val="2E75B6"/>
-          </a:solidFill>
-          <a:ln>
-            <a:noFill/>
-          </a:ln>
-          <a:effectLst/>
-        </p:spPr>
-        <p:style>
-          <a:lnRef idx="1">
-            <a:schemeClr val="accent1"/>
-          </a:lnRef>
-          <a:fillRef idx="3">
-            <a:schemeClr val="accent1"/>
-          </a:fillRef>
-          <a:effectRef idx="2">
-            <a:schemeClr val="accent1"/>
-          </a:effectRef>
-          <a:fontRef idx="minor">
-            <a:schemeClr val="lt1"/>
-          </a:fontRef>
-        </p:style>
-        <p:txBody>
-          <a:bodyPr rtlCol="0" anchor="ctr"/>
-          <a:lstStyle/>
-          <a:p>
-            <a:pPr algn="ctr"/>
-          </a:p>
-        </p:txBody>
-      </p:sp>
-      <p:sp>
-        <p:nvSpPr>
-          <p:cNvPr id="14" name="TextBox 13"/>
+              <a:t>SNP $337.50/drum</a:t>
+            </a:r>
+          </a:p>
+        </p:txBody>
+      </p:sp>
+      <p:sp>
+        <p:nvSpPr>
+          <p:cNvPr id="13" name="TextBox 12"/>
           <p:cNvSpPr txBox="1"/>
           <p:nvPr/>
         </p:nvSpPr>
         <p:spPr>
           <a:xfrm>
-            <a:off x="731520" y="3163824"/>
-            <a:ext cx="10789920" cy="365760"/>
+            <a:off x="548640" y="2697480"/>
+            <a:ext cx="11064240" cy="365760"/>
           </a:xfrm>
           <a:prstGeom prst="rect">
             <a:avLst/>
@@ -5006,324 +4962,431 @@
               </a:spcAft>
             </a:pPr>
             <a:r>
-              <a:rPr sz="1500" b="1" i="0">
-                <a:solidFill>
-                  <a:srgbClr val="FFFFFF"/>
-                </a:solidFill>
-                <a:latin typeface="Calibri"/>
-              </a:rPr>
-              <a:t>DECIDED PLAN — 1 drum/week to the second source (~35% of volume)</a:t>
-            </a:r>
-          </a:p>
-        </p:txBody>
-      </p:sp>
-      <p:sp>
-        <p:nvSpPr>
-          <p:cNvPr id="15" name="Rectangle 14"/>
-          <p:cNvSpPr/>
-          <p:nvPr/>
-        </p:nvSpPr>
-        <p:spPr>
-          <a:xfrm>
-            <a:off x="548640" y="3749039"/>
-            <a:ext cx="3566160" cy="1554480"/>
-          </a:xfrm>
-          <a:prstGeom prst="rect">
-            <a:avLst/>
-          </a:prstGeom>
-          <a:solidFill>
-            <a:srgbClr val="EEF3FA"/>
-          </a:solidFill>
-          <a:ln>
-            <a:noFill/>
-          </a:ln>
-          <a:effectLst/>
-        </p:spPr>
-        <p:style>
-          <a:lnRef idx="1">
-            <a:schemeClr val="accent1"/>
-          </a:lnRef>
-          <a:fillRef idx="3">
-            <a:schemeClr val="accent1"/>
-          </a:fillRef>
-          <a:effectRef idx="2">
-            <a:schemeClr val="accent1"/>
-          </a:effectRef>
-          <a:fontRef idx="minor">
-            <a:schemeClr val="lt1"/>
-          </a:fontRef>
-        </p:style>
-        <p:txBody>
-          <a:bodyPr rtlCol="0" anchor="ctr"/>
-          <a:lstStyle/>
-          <a:p>
-            <a:pPr algn="ctr"/>
-          </a:p>
-        </p:txBody>
-      </p:sp>
-      <p:sp>
-        <p:nvSpPr>
-          <p:cNvPr id="16" name="TextBox 15"/>
+              <a:rPr sz="1300" b="1" i="0">
+                <a:solidFill>
+                  <a:srgbClr val="1F4E78"/>
+                </a:solidFill>
+                <a:latin typeface="Calibri"/>
+              </a:rPr>
+              <a:t>Annual PREMIUM over the all-SNP baseline (the cost of redundancy) — selected scenarios:</a:t>
+            </a:r>
+          </a:p>
+        </p:txBody>
+      </p:sp>
+      <p:graphicFrame>
+        <p:nvGraphicFramePr>
+          <p:cNvPr id="14" name="Table 13"/>
+          <p:cNvGraphicFramePr>
+            <a:graphicFrameLocks noGrp="1"/>
+          </p:cNvGraphicFramePr>
+          <p:nvPr/>
+        </p:nvGraphicFramePr>
+        <p:xfrm>
+          <a:off x="548640" y="3108960"/>
+          <a:ext cx="11064240" cy="1965960"/>
+        </p:xfrm>
+        <a:graphic>
+          <a:graphicData uri="http://schemas.openxmlformats.org/drawingml/2006/table">
+            <a:tbl>
+              <a:tblPr firstRow="1" bandRow="1">
+                <a:tableStyleId>{5C22544A-7EE6-4342-B048-85BDC9FD1C3A}</a:tableStyleId>
+              </a:tblPr>
+              <a:tblGrid>
+                <a:gridCol w="3383280"/>
+                <a:gridCol w="2560320"/>
+                <a:gridCol w="2560320"/>
+                <a:gridCol w="2560320"/>
+              </a:tblGrid>
+              <a:tr h="491490">
+                <a:tc>
+                  <a:txBody>
+                    <a:bodyPr/>
+                    <a:lstStyle/>
+                    <a:p>
+                      <a:pPr algn="l"/>
+                      <a:r>
+                        <a:rPr sz="1300" b="1">
+                          <a:solidFill>
+                            <a:srgbClr val="FFFFFF"/>
+                          </a:solidFill>
+                          <a:latin typeface="Calibri"/>
+                        </a:rPr>
+                        <a:t>Allocation to 2nd source</a:t>
+                      </a:r>
+                    </a:p>
+                  </a:txBody>
+                  <a:tcPr>
+                    <a:solidFill>
+                      <a:srgbClr val="1F4E78"/>
+                    </a:solidFill>
+                  </a:tcPr>
+                </a:tc>
+                <a:tc>
+                  <a:txBody>
+                    <a:bodyPr/>
+                    <a:lstStyle/>
+                    <a:p>
+                      <a:pPr algn="ctr"/>
+                      <a:r>
+                        <a:rPr sz="1300" b="1">
+                          <a:solidFill>
+                            <a:srgbClr val="FFFFFF"/>
+                          </a:solidFill>
+                          <a:latin typeface="Calibri"/>
+                        </a:rPr>
+                        <a:t>2nd +50% / SNP holds</a:t>
+                      </a:r>
+                    </a:p>
+                  </a:txBody>
+                  <a:tcPr>
+                    <a:solidFill>
+                      <a:srgbClr val="1F4E78"/>
+                    </a:solidFill>
+                  </a:tcPr>
+                </a:tc>
+                <a:tc>
+                  <a:txBody>
+                    <a:bodyPr/>
+                    <a:lstStyle/>
+                    <a:p>
+                      <a:pPr algn="ctr"/>
+                      <a:r>
+                        <a:rPr sz="1300" b="1">
+                          <a:solidFill>
+                            <a:srgbClr val="FFFFFF"/>
+                          </a:solidFill>
+                          <a:latin typeface="Calibri"/>
+                        </a:rPr>
+                        <a:t>2nd +50% / SNP +10%</a:t>
+                      </a:r>
+                    </a:p>
+                  </a:txBody>
+                  <a:tcPr>
+                    <a:solidFill>
+                      <a:srgbClr val="1F4E78"/>
+                    </a:solidFill>
+                  </a:tcPr>
+                </a:tc>
+                <a:tc>
+                  <a:txBody>
+                    <a:bodyPr/>
+                    <a:lstStyle/>
+                    <a:p>
+                      <a:pPr algn="ctr"/>
+                      <a:r>
+                        <a:rPr sz="1300" b="1">
+                          <a:solidFill>
+                            <a:srgbClr val="FFFFFF"/>
+                          </a:solidFill>
+                          <a:latin typeface="Calibri"/>
+                        </a:rPr>
+                        <a:t>2nd +100% / SNP +20%</a:t>
+                      </a:r>
+                    </a:p>
+                  </a:txBody>
+                  <a:tcPr>
+                    <a:solidFill>
+                      <a:srgbClr val="1F4E78"/>
+                    </a:solidFill>
+                  </a:tcPr>
+                </a:tc>
+              </a:tr>
+              <a:tr h="491490">
+                <a:tc>
+                  <a:txBody>
+                    <a:bodyPr/>
+                    <a:lstStyle/>
+                    <a:p>
+                      <a:pPr algn="l"/>
+                      <a:r>
+                        <a:rPr sz="1300" b="1">
+                          <a:solidFill>
+                            <a:srgbClr val="1F4E78"/>
+                          </a:solidFill>
+                          <a:latin typeface="Calibri"/>
+                        </a:rPr>
+                        <a:t>20%  (~0.6 drum/wk)</a:t>
+                      </a:r>
+                    </a:p>
+                  </a:txBody>
+                  <a:tcPr>
+                    <a:solidFill>
+                      <a:srgbClr val="FFFFFF"/>
+                    </a:solidFill>
+                  </a:tcPr>
+                </a:tc>
+                <a:tc>
+                  <a:txBody>
+                    <a:bodyPr/>
+                    <a:lstStyle/>
+                    <a:p>
+                      <a:pPr algn="ctr"/>
+                      <a:r>
+                        <a:rPr sz="1300">
+                          <a:solidFill>
+                            <a:srgbClr val="1F4E78"/>
+                          </a:solidFill>
+                          <a:latin typeface="Calibri"/>
+                        </a:rPr>
+                        <a:t>$5,070</a:t>
+                      </a:r>
+                    </a:p>
+                  </a:txBody>
+                  <a:tcPr>
+                    <a:solidFill>
+                      <a:srgbClr val="E2EFDA"/>
+                    </a:solidFill>
+                  </a:tcPr>
+                </a:tc>
+                <a:tc>
+                  <a:txBody>
+                    <a:bodyPr/>
+                    <a:lstStyle/>
+                    <a:p>
+                      <a:pPr algn="ctr"/>
+                      <a:r>
+                        <a:rPr sz="1300">
+                          <a:solidFill>
+                            <a:srgbClr val="1F4E78"/>
+                          </a:solidFill>
+                          <a:latin typeface="Calibri"/>
+                        </a:rPr>
+                        <a:t>$9,126</a:t>
+                      </a:r>
+                    </a:p>
+                  </a:txBody>
+                  <a:tcPr>
+                    <a:solidFill>
+                      <a:srgbClr val="FFF2CC"/>
+                    </a:solidFill>
+                  </a:tcPr>
+                </a:tc>
+                <a:tc>
+                  <a:txBody>
+                    <a:bodyPr/>
+                    <a:lstStyle/>
+                    <a:p>
+                      <a:pPr algn="ctr"/>
+                      <a:r>
+                        <a:rPr sz="1300">
+                          <a:solidFill>
+                            <a:srgbClr val="1F4E78"/>
+                          </a:solidFill>
+                          <a:latin typeface="Calibri"/>
+                        </a:rPr>
+                        <a:t>$18,252</a:t>
+                      </a:r>
+                    </a:p>
+                  </a:txBody>
+                  <a:tcPr>
+                    <a:solidFill>
+                      <a:srgbClr val="FCE4D6"/>
+                    </a:solidFill>
+                  </a:tcPr>
+                </a:tc>
+              </a:tr>
+              <a:tr h="491490">
+                <a:tc>
+                  <a:txBody>
+                    <a:bodyPr/>
+                    <a:lstStyle/>
+                    <a:p>
+                      <a:pPr algn="l"/>
+                      <a:r>
+                        <a:rPr sz="1300" b="1">
+                          <a:solidFill>
+                            <a:srgbClr val="1F4E78"/>
+                          </a:solidFill>
+                          <a:latin typeface="Calibri"/>
+                        </a:rPr>
+                        <a:t>35%  (~1 drum/wk)</a:t>
+                      </a:r>
+                    </a:p>
+                  </a:txBody>
+                  <a:tcPr>
+                    <a:solidFill>
+                      <a:srgbClr val="FFFFFF"/>
+                    </a:solidFill>
+                  </a:tcPr>
+                </a:tc>
+                <a:tc>
+                  <a:txBody>
+                    <a:bodyPr/>
+                    <a:lstStyle/>
+                    <a:p>
+                      <a:pPr algn="ctr"/>
+                      <a:r>
+                        <a:rPr sz="1300">
+                          <a:solidFill>
+                            <a:srgbClr val="1F4E78"/>
+                          </a:solidFill>
+                          <a:latin typeface="Calibri"/>
+                        </a:rPr>
+                        <a:t>$8,872</a:t>
+                      </a:r>
+                    </a:p>
+                  </a:txBody>
+                  <a:tcPr>
+                    <a:solidFill>
+                      <a:srgbClr val="E2EFDA"/>
+                    </a:solidFill>
+                  </a:tcPr>
+                </a:tc>
+                <a:tc>
+                  <a:txBody>
+                    <a:bodyPr/>
+                    <a:lstStyle/>
+                    <a:p>
+                      <a:pPr algn="ctr"/>
+                      <a:r>
+                        <a:rPr sz="1300">
+                          <a:solidFill>
+                            <a:srgbClr val="1F4E78"/>
+                          </a:solidFill>
+                          <a:latin typeface="Calibri"/>
+                        </a:rPr>
+                        <a:t>$12,168</a:t>
+                      </a:r>
+                    </a:p>
+                  </a:txBody>
+                  <a:tcPr>
+                    <a:solidFill>
+                      <a:srgbClr val="FFF2CC"/>
+                    </a:solidFill>
+                  </a:tcPr>
+                </a:tc>
+                <a:tc>
+                  <a:txBody>
+                    <a:bodyPr/>
+                    <a:lstStyle/>
+                    <a:p>
+                      <a:pPr algn="ctr"/>
+                      <a:r>
+                        <a:rPr sz="1300">
+                          <a:solidFill>
+                            <a:srgbClr val="1F4E78"/>
+                          </a:solidFill>
+                          <a:latin typeface="Calibri"/>
+                        </a:rPr>
+                        <a:t>$24,336</a:t>
+                      </a:r>
+                    </a:p>
+                  </a:txBody>
+                  <a:tcPr>
+                    <a:solidFill>
+                      <a:srgbClr val="FCE4D6"/>
+                    </a:solidFill>
+                  </a:tcPr>
+                </a:tc>
+              </a:tr>
+              <a:tr h="491490">
+                <a:tc>
+                  <a:txBody>
+                    <a:bodyPr/>
+                    <a:lstStyle/>
+                    <a:p>
+                      <a:pPr algn="l"/>
+                      <a:r>
+                        <a:rPr sz="1300" b="1">
+                          <a:solidFill>
+                            <a:srgbClr val="1F4E78"/>
+                          </a:solidFill>
+                          <a:latin typeface="Calibri"/>
+                        </a:rPr>
+                        <a:t>50%  (~1.4 drum/wk)</a:t>
+                      </a:r>
+                    </a:p>
+                  </a:txBody>
+                  <a:tcPr>
+                    <a:solidFill>
+                      <a:srgbClr val="FFFFFF"/>
+                    </a:solidFill>
+                  </a:tcPr>
+                </a:tc>
+                <a:tc>
+                  <a:txBody>
+                    <a:bodyPr/>
+                    <a:lstStyle/>
+                    <a:p>
+                      <a:pPr algn="ctr"/>
+                      <a:r>
+                        <a:rPr sz="1300">
+                          <a:solidFill>
+                            <a:srgbClr val="1F4E78"/>
+                          </a:solidFill>
+                          <a:latin typeface="Calibri"/>
+                        </a:rPr>
+                        <a:t>$12,675</a:t>
+                      </a:r>
+                    </a:p>
+                  </a:txBody>
+                  <a:tcPr>
+                    <a:solidFill>
+                      <a:srgbClr val="E2EFDA"/>
+                    </a:solidFill>
+                  </a:tcPr>
+                </a:tc>
+                <a:tc>
+                  <a:txBody>
+                    <a:bodyPr/>
+                    <a:lstStyle/>
+                    <a:p>
+                      <a:pPr algn="ctr"/>
+                      <a:r>
+                        <a:rPr sz="1300">
+                          <a:solidFill>
+                            <a:srgbClr val="1F4E78"/>
+                          </a:solidFill>
+                          <a:latin typeface="Calibri"/>
+                        </a:rPr>
+                        <a:t>$15,210</a:t>
+                      </a:r>
+                    </a:p>
+                  </a:txBody>
+                  <a:tcPr>
+                    <a:solidFill>
+                      <a:srgbClr val="FFF2CC"/>
+                    </a:solidFill>
+                  </a:tcPr>
+                </a:tc>
+                <a:tc>
+                  <a:txBody>
+                    <a:bodyPr/>
+                    <a:lstStyle/>
+                    <a:p>
+                      <a:pPr algn="ctr"/>
+                      <a:r>
+                        <a:rPr sz="1300">
+                          <a:solidFill>
+                            <a:srgbClr val="1F4E78"/>
+                          </a:solidFill>
+                          <a:latin typeface="Calibri"/>
+                        </a:rPr>
+                        <a:t>$30,420</a:t>
+                      </a:r>
+                    </a:p>
+                  </a:txBody>
+                  <a:tcPr>
+                    <a:solidFill>
+                      <a:srgbClr val="FCE4D6"/>
+                    </a:solidFill>
+                  </a:tcPr>
+                </a:tc>
+              </a:tr>
+            </a:tbl>
+          </a:graphicData>
+        </a:graphic>
+      </p:graphicFrame>
+      <p:sp>
+        <p:nvSpPr>
+          <p:cNvPr id="15" name="TextBox 14"/>
           <p:cNvSpPr txBox="1"/>
           <p:nvPr/>
         </p:nvSpPr>
         <p:spPr>
           <a:xfrm>
-            <a:off x="640080" y="3886200"/>
-            <a:ext cx="3383279" cy="1280160"/>
-          </a:xfrm>
-          <a:prstGeom prst="rect">
-            <a:avLst/>
-          </a:prstGeom>
-          <a:noFill/>
-        </p:spPr>
-        <p:txBody>
-          <a:bodyPr wrap="square" anchor="ctr">
-            <a:spAutoFit/>
-          </a:bodyPr>
-          <a:lstStyle/>
-          <a:p>
-            <a:pPr algn="ctr">
-              <a:spcAft>
-                <a:spcPts val="200"/>
-              </a:spcAft>
-            </a:pPr>
-            <a:r>
-              <a:rPr sz="2400" b="1" i="0">
-                <a:solidFill>
-                  <a:srgbClr val="376E37"/>
-                </a:solidFill>
-                <a:latin typeface="Calibri"/>
-              </a:rPr>
-              <a:t>52 drums/yr</a:t>
-            </a:r>
-          </a:p>
-          <a:p>
-            <a:pPr algn="ctr">
-              <a:spcAft>
-                <a:spcPts val="400"/>
-              </a:spcAft>
-            </a:pPr>
-            <a:r>
-              <a:rPr sz="1100" b="0" i="0">
-                <a:solidFill>
-                  <a:srgbClr val="595959"/>
-                </a:solidFill>
-                <a:latin typeface="Calibri"/>
-              </a:rPr>
-              <a:t>To 2nd source (34.6%) ≈ $26,325</a:t>
-            </a:r>
-          </a:p>
-        </p:txBody>
-      </p:sp>
-      <p:sp>
-        <p:nvSpPr>
-          <p:cNvPr id="17" name="Rectangle 16"/>
-          <p:cNvSpPr/>
-          <p:nvPr/>
-        </p:nvSpPr>
-        <p:spPr>
-          <a:xfrm>
-            <a:off x="4297680" y="3749039"/>
-            <a:ext cx="3566160" cy="1554480"/>
-          </a:xfrm>
-          <a:prstGeom prst="rect">
-            <a:avLst/>
-          </a:prstGeom>
-          <a:solidFill>
-            <a:srgbClr val="EEF3FA"/>
-          </a:solidFill>
-          <a:ln>
-            <a:noFill/>
-          </a:ln>
-          <a:effectLst/>
-        </p:spPr>
-        <p:style>
-          <a:lnRef idx="1">
-            <a:schemeClr val="accent1"/>
-          </a:lnRef>
-          <a:fillRef idx="3">
-            <a:schemeClr val="accent1"/>
-          </a:fillRef>
-          <a:effectRef idx="2">
-            <a:schemeClr val="accent1"/>
-          </a:effectRef>
-          <a:fontRef idx="minor">
-            <a:schemeClr val="lt1"/>
-          </a:fontRef>
-        </p:style>
-        <p:txBody>
-          <a:bodyPr rtlCol="0" anchor="ctr"/>
-          <a:lstStyle/>
-          <a:p>
-            <a:pPr algn="ctr"/>
-          </a:p>
-        </p:txBody>
-      </p:sp>
-      <p:sp>
-        <p:nvSpPr>
-          <p:cNvPr id="18" name="TextBox 17"/>
-          <p:cNvSpPr txBox="1"/>
-          <p:nvPr/>
-        </p:nvSpPr>
-        <p:spPr>
-          <a:xfrm>
-            <a:off x="4389120" y="3886200"/>
-            <a:ext cx="3383279" cy="1280160"/>
-          </a:xfrm>
-          <a:prstGeom prst="rect">
-            <a:avLst/>
-          </a:prstGeom>
-          <a:noFill/>
-        </p:spPr>
-        <p:txBody>
-          <a:bodyPr wrap="square" anchor="ctr">
-            <a:spAutoFit/>
-          </a:bodyPr>
-          <a:lstStyle/>
-          <a:p>
-            <a:pPr algn="ctr">
-              <a:spcAft>
-                <a:spcPts val="200"/>
-              </a:spcAft>
-            </a:pPr>
-            <a:r>
-              <a:rPr sz="2400" b="1" i="0">
-                <a:solidFill>
-                  <a:srgbClr val="1F4E78"/>
-                </a:solidFill>
-                <a:latin typeface="Calibri"/>
-              </a:rPr>
-              <a:t>~98 drums/yr</a:t>
-            </a:r>
-          </a:p>
-          <a:p>
-            <a:pPr algn="ctr">
-              <a:spcAft>
-                <a:spcPts val="400"/>
-              </a:spcAft>
-            </a:pPr>
-            <a:r>
-              <a:rPr sz="1100" b="0" i="0">
-                <a:solidFill>
-                  <a:srgbClr val="595959"/>
-                </a:solidFill>
-                <a:latin typeface="Calibri"/>
-              </a:rPr>
-              <a:t>SNP retained ≈ $33,150</a:t>
-            </a:r>
-          </a:p>
-        </p:txBody>
-      </p:sp>
-      <p:sp>
-        <p:nvSpPr>
-          <p:cNvPr id="19" name="Rectangle 18"/>
-          <p:cNvSpPr/>
-          <p:nvPr/>
-        </p:nvSpPr>
-        <p:spPr>
-          <a:xfrm>
-            <a:off x="8046720" y="3749039"/>
-            <a:ext cx="3566160" cy="1554480"/>
-          </a:xfrm>
-          <a:prstGeom prst="rect">
-            <a:avLst/>
-          </a:prstGeom>
-          <a:solidFill>
-            <a:srgbClr val="EEF3FA"/>
-          </a:solidFill>
-          <a:ln>
-            <a:noFill/>
-          </a:ln>
-          <a:effectLst/>
-        </p:spPr>
-        <p:style>
-          <a:lnRef idx="1">
-            <a:schemeClr val="accent1"/>
-          </a:lnRef>
-          <a:fillRef idx="3">
-            <a:schemeClr val="accent1"/>
-          </a:fillRef>
-          <a:effectRef idx="2">
-            <a:schemeClr val="accent1"/>
-          </a:effectRef>
-          <a:fontRef idx="minor">
-            <a:schemeClr val="lt1"/>
-          </a:fontRef>
-        </p:style>
-        <p:txBody>
-          <a:bodyPr rtlCol="0" anchor="ctr"/>
-          <a:lstStyle/>
-          <a:p>
-            <a:pPr algn="ctr"/>
-          </a:p>
-        </p:txBody>
-      </p:sp>
-      <p:sp>
-        <p:nvSpPr>
-          <p:cNvPr id="20" name="TextBox 19"/>
-          <p:cNvSpPr txBox="1"/>
-          <p:nvPr/>
-        </p:nvSpPr>
-        <p:spPr>
-          <a:xfrm>
-            <a:off x="8138160" y="3886200"/>
-            <a:ext cx="3383279" cy="1280160"/>
-          </a:xfrm>
-          <a:prstGeom prst="rect">
-            <a:avLst/>
-          </a:prstGeom>
-          <a:noFill/>
-        </p:spPr>
-        <p:txBody>
-          <a:bodyPr wrap="square" anchor="ctr">
-            <a:spAutoFit/>
-          </a:bodyPr>
-          <a:lstStyle/>
-          <a:p>
-            <a:pPr algn="ctr">
-              <a:spcAft>
-                <a:spcPts val="200"/>
-              </a:spcAft>
-            </a:pPr>
-            <a:r>
-              <a:rPr sz="2400" b="1" i="0">
-                <a:solidFill>
-                  <a:srgbClr val="9C7706"/>
-                </a:solidFill>
-                <a:latin typeface="Calibri"/>
-              </a:rPr>
-              <a:t>+$8,800/yr</a:t>
-            </a:r>
-          </a:p>
-          <a:p>
-            <a:pPr algn="ctr">
-              <a:spcAft>
-                <a:spcPts val="400"/>
-              </a:spcAft>
-            </a:pPr>
-            <a:r>
-              <a:rPr sz="1100" b="0" i="0">
-                <a:solidFill>
-                  <a:srgbClr val="595959"/>
-                </a:solidFill>
-                <a:latin typeface="Calibri"/>
-              </a:rPr>
-              <a:t>Redundancy premium (+17%)</a:t>
-            </a:r>
-          </a:p>
-        </p:txBody>
-      </p:sp>
-      <p:sp>
-        <p:nvSpPr>
-          <p:cNvPr id="21" name="TextBox 20"/>
-          <p:cNvSpPr txBox="1"/>
-          <p:nvPr/>
-        </p:nvSpPr>
-        <p:spPr>
-          <a:xfrm>
-            <a:off x="548640" y="5532120"/>
-            <a:ext cx="11064240" cy="914400"/>
+            <a:off x="548640" y="5257800"/>
+            <a:ext cx="11064240" cy="1188720"/>
           </a:xfrm>
           <a:prstGeom prst="rect">
             <a:avLst/>
@@ -5348,7 +5411,7 @@
                 </a:solidFill>
                 <a:latin typeface="Calibri"/>
               </a:rPr>
-              <a:t>The premium is the cost of insurance against single-source failure. A ~35% allocation (vs. 20–25%) keeps the 2nd source genuinely practiced given the short shelf life — trade-off: more volume pulled from SNP. (Price = +50% small-batch assumption until a real quote lands.)</a:t>
+              <a:t>At price parity with SNP holding, the cost is ~$0 (ideal, unlikely). KEY: an SNP price increase hits the LARGER retained volume — it can cost more than the 2nd-source premium itself. Range across scenarios ~$2.5k–$30k/yr. Nothing decided; full interactive matrix in the model.</a:t>
             </a:r>
           </a:p>
         </p:txBody>

</xml_diff>

<commit_message>
Apply hard cap: 2nd source gets no more than 1 drum/week
- Model: allocation labeled HARD CAP=1; cost matrix + split notes flag
  35% (~1 drum/wk) as the cap and 50% as reference-only
- Slides: cost table drops over-cap row; pricing slide swaps the 2-drum
  batch lever for steady-weekly-PO (capped at 1/wk); cadence slide
  reframed to weekly single-drum as recommended; summary range -> ~$0-24k
- Report: cost table + ranges updated for the cap

Co-Authored-By: Claude Opus 4.8 <noreply@anthropic.com>
Claude-Session: https://claude.ai/code/session_01LkE2ZRYs3PLyj8XHTsU3i4
</commit_message>
<xml_diff>
--- a/PVA second supplier initiative/PVA_Second_Source_Slides.pptx
+++ b/PVA second supplier initiative/PVA_Second_Source_Slides.pptx
@@ -5412,7 +5412,7 @@
                 </a:solidFill>
                 <a:latin typeface="Calibri"/>
               </a:rPr>
-              <a:t>•  If SNP holds price: redundancy is modest — ~$5–13k/yr depending on split &amp; 2nd-source premium (≈$0 at parity).</a:t>
+              <a:t>•  Capped at 1 drum/week (~35%): if SNP holds price, redundancy ≈ $6–12k/yr at the proposed $1.00–1.25/lb band (≈$0 at parity).</a:t>
             </a:r>
           </a:p>
           <a:p>
@@ -5428,7 +5428,7 @@
                 </a:solidFill>
                 <a:latin typeface="Calibri"/>
               </a:rPr>
-              <a:t>•  If SNP raises price on the reduced volume: cost can roughly double — that surcharge, on the larger retained volume, is often the bigger driver.</a:t>
+              <a:t>•  If SNP raises price on the reduced volume: that surcharge — on the larger retained volume — is often the bigger driver.</a:t>
             </a:r>
           </a:p>
           <a:p>
@@ -5444,7 +5444,7 @@
                 </a:solidFill>
                 <a:latin typeface="Calibri"/>
               </a:rPr>
-              <a:t>•  Range across plausible scenarios: ~$2.5k to ~$30k/yr.</a:t>
+              <a:t>•  Range at the cap: ~$0 to ~$24k/yr (worst case = top price + SNP also raising).</a:t>
             </a:r>
           </a:p>
           <a:p>
@@ -6921,7 +6921,7 @@
         </p:nvGraphicFramePr>
         <p:xfrm>
           <a:off x="548640" y="3108960"/>
-          <a:ext cx="11064240" cy="1965960"/>
+          <a:ext cx="11064240" cy="1554480"/>
         </p:xfrm>
         <a:graphic>
           <a:graphicData uri="http://schemas.openxmlformats.org/drawingml/2006/table">
@@ -6935,7 +6935,7 @@
                 <a:gridCol w="2560320"/>
                 <a:gridCol w="2560320"/>
               </a:tblGrid>
-              <a:tr h="491490">
+              <a:tr h="518160">
                 <a:tc>
                   <a:txBody>
                     <a:bodyPr/>
@@ -7029,7 +7029,7 @@
                   </a:tcPr>
                 </a:tc>
               </a:tr>
-              <a:tr h="491490">
+              <a:tr h="518160">
                 <a:tc>
                   <a:txBody>
                     <a:bodyPr/>
@@ -7123,7 +7123,7 @@
                   </a:tcPr>
                 </a:tc>
               </a:tr>
-              <a:tr h="491490">
+              <a:tr h="518160">
                 <a:tc>
                   <a:txBody>
                     <a:bodyPr/>
@@ -7137,7 +7137,7 @@
                           </a:solidFill>
                           <a:latin typeface="Calibri"/>
                         </a:rPr>
-                        <a:t>35%  (~1 drum/wk)</a:t>
+                        <a:t>35%  (~1 drum/wk — CAP)</a:t>
                       </a:r>
                     </a:p>
                   </a:txBody>
@@ -7217,100 +7217,6 @@
                   </a:tcPr>
                 </a:tc>
               </a:tr>
-              <a:tr h="491490">
-                <a:tc>
-                  <a:txBody>
-                    <a:bodyPr/>
-                    <a:lstStyle/>
-                    <a:p>
-                      <a:pPr algn="l"/>
-                      <a:r>
-                        <a:rPr sz="1300" b="1">
-                          <a:solidFill>
-                            <a:srgbClr val="1F4E78"/>
-                          </a:solidFill>
-                          <a:latin typeface="Calibri"/>
-                        </a:rPr>
-                        <a:t>50%  (~1.4 drum/wk)</a:t>
-                      </a:r>
-                    </a:p>
-                  </a:txBody>
-                  <a:tcPr>
-                    <a:solidFill>
-                      <a:srgbClr val="FFFFFF"/>
-                    </a:solidFill>
-                  </a:tcPr>
-                </a:tc>
-                <a:tc>
-                  <a:txBody>
-                    <a:bodyPr/>
-                    <a:lstStyle/>
-                    <a:p>
-                      <a:pPr algn="ctr"/>
-                      <a:r>
-                        <a:rPr sz="1300">
-                          <a:solidFill>
-                            <a:srgbClr val="1F4E78"/>
-                          </a:solidFill>
-                          <a:latin typeface="Calibri"/>
-                        </a:rPr>
-                        <a:t>$12,675</a:t>
-                      </a:r>
-                    </a:p>
-                  </a:txBody>
-                  <a:tcPr>
-                    <a:solidFill>
-                      <a:srgbClr val="E2EFDA"/>
-                    </a:solidFill>
-                  </a:tcPr>
-                </a:tc>
-                <a:tc>
-                  <a:txBody>
-                    <a:bodyPr/>
-                    <a:lstStyle/>
-                    <a:p>
-                      <a:pPr algn="ctr"/>
-                      <a:r>
-                        <a:rPr sz="1300">
-                          <a:solidFill>
-                            <a:srgbClr val="1F4E78"/>
-                          </a:solidFill>
-                          <a:latin typeface="Calibri"/>
-                        </a:rPr>
-                        <a:t>$15,210</a:t>
-                      </a:r>
-                    </a:p>
-                  </a:txBody>
-                  <a:tcPr>
-                    <a:solidFill>
-                      <a:srgbClr val="FFF2CC"/>
-                    </a:solidFill>
-                  </a:tcPr>
-                </a:tc>
-                <a:tc>
-                  <a:txBody>
-                    <a:bodyPr/>
-                    <a:lstStyle/>
-                    <a:p>
-                      <a:pPr algn="ctr"/>
-                      <a:r>
-                        <a:rPr sz="1300">
-                          <a:solidFill>
-                            <a:srgbClr val="1F4E78"/>
-                          </a:solidFill>
-                          <a:latin typeface="Calibri"/>
-                        </a:rPr>
-                        <a:t>$30,420</a:t>
-                      </a:r>
-                    </a:p>
-                  </a:txBody>
-                  <a:tcPr>
-                    <a:solidFill>
-                      <a:srgbClr val="FCE4D6"/>
-                    </a:solidFill>
-                  </a:tcPr>
-                </a:tc>
-              </a:tr>
             </a:tbl>
           </a:graphicData>
         </a:graphic>
@@ -7349,7 +7255,7 @@
                 </a:solidFill>
                 <a:latin typeface="Calibri"/>
               </a:rPr>
-              <a:t>At price parity with SNP holding, the cost is ~$0 (ideal, unlikely). KEY: an SNP price increase hits the LARGER retained volume — it can cost more than the 2nd-source premium itself. Range across scenarios ~$2.5k–$30k/yr. Nothing decided; full interactive matrix in the model.</a:t>
+              <a:t>Capped at 1 drum/week (~35%). At parity with SNP holding, cost ≈ $0 (ideal, unlikely). KEY: an SNP price increase hits the LARGER retained volume — it can cost more than the 2nd-source premium itself. Range at the cap ≈ $0–$24k/yr. Nothing decided; full matrix in the model.</a:t>
             </a:r>
           </a:p>
         </p:txBody>
@@ -7522,7 +7428,7 @@
               </a:spcAft>
             </a:pPr>
             <a:r>
-              <a:rPr b="1" sz="1300">
+              <a:rPr b="1" sz="1250">
                 <a:solidFill>
                   <a:srgbClr val="1F4E78"/>
                 </a:solidFill>
@@ -7531,7 +7437,7 @@
               <a:t>• Benchmark </a:t>
             </a:r>
             <a:r>
-              <a:rPr sz="1300">
+              <a:rPr sz="1250">
                 <a:solidFill>
                   <a:srgbClr val="595959"/>
                 </a:solidFill>
@@ -7547,7 +7453,7 @@
               </a:spcAft>
             </a:pPr>
             <a:r>
-              <a:rPr b="1" sz="1300">
+              <a:rPr b="1" sz="1250">
                 <a:solidFill>
                   <a:srgbClr val="1F4E78"/>
                 </a:solidFill>
@@ -7556,13 +7462,13 @@
               <a:t>• A premium is fair </a:t>
             </a:r>
             <a:r>
-              <a:rPr sz="1300">
+              <a:rPr sz="1250">
                 <a:solidFill>
                   <a:srgbClr val="595959"/>
                 </a:solidFill>
                 <a:latin typeface="Calibri"/>
               </a:rPr>
-              <a:t>— APV is a mid-size coatings house; a single 55-gal drum is a small batch. Their cost floor alone is ~$0.80–1.15/lb.</a:t>
+              <a:t>— capped at 1 drum/wk, APV runs single 55-gal batches. They do small batches (from 5 gal), so it's workable — but small batches carry a premium; cost floor ~$0.80–1.15/lb.</a:t>
             </a:r>
           </a:p>
           <a:p>
@@ -7572,7 +7478,7 @@
               </a:spcAft>
             </a:pPr>
             <a:r>
-              <a:rPr b="1" sz="1300">
+              <a:rPr b="1" sz="1250">
                 <a:solidFill>
                   <a:srgbClr val="1F4E78"/>
                 </a:solidFill>
@@ -7581,7 +7487,7 @@
               <a:t>• Don't expect parity </a:t>
             </a:r>
             <a:r>
-              <a:rPr sz="1300">
+              <a:rPr sz="1250">
                 <a:solidFill>
                   <a:srgbClr val="595959"/>
                 </a:solidFill>
@@ -7718,7 +7624,7 @@
                 </a:solidFill>
                 <a:latin typeface="Calibri"/>
               </a:rPr>
-              <a:t>•  Lever: batch 2 drums/run (110 gal) = their batch sweet spot → holds price down</a:t>
+              <a:t>•  Lever: steady, predictable weekly PO — easy to plan; worth more to a small shop than volume</a:t>
             </a:r>
           </a:p>
         </p:txBody>
@@ -8356,7 +8262,7 @@
                 </a:solidFill>
                 <a:latin typeface="Calibri"/>
               </a:rPr>
-              <a:t>Order Cadence — Driven by the 18-Day Shelf Life</a:t>
+              <a:t>Order Cadence — 1 Drum/Week Within the 18-Day Shelf Life</a:t>
             </a:r>
           </a:p>
         </p:txBody>
@@ -8434,7 +8340,7 @@
                 </a:solidFill>
                 <a:latin typeface="Calibri"/>
               </a:rPr>
-              <a:t>• Made fresh, no stockpiling </a:t>
+              <a:t>• Hard cap </a:t>
             </a:r>
             <a:r>
               <a:rPr sz="1500">
@@ -8443,7 +8349,7 @@
                 </a:solidFill>
                 <a:latin typeface="Calibri"/>
               </a:rPr>
-              <a:t>— 18-day shelf life (~2.5 weeks). You can hold at most ~2 drums of 2nd-source supply before the oldest ages out.</a:t>
+              <a:t>— no more than 1 drum/week to this supplier (~35% of total). Made fresh; the 18-day shelf life (~2.5 wks) easily covers a weekly drum.</a:t>
             </a:r>
           </a:p>
           <a:p>
@@ -8459,7 +8365,7 @@
                 </a:solidFill>
                 <a:latin typeface="Calibri"/>
               </a:rPr>
-              <a:t>• Same split </a:t>
+              <a:t>• APV does small batches (from 5 gal) </a:t>
             </a:r>
             <a:r>
               <a:rPr sz="1500">
@@ -8468,7 +8374,7 @@
                 </a:solidFill>
                 <a:latin typeface="Calibri"/>
               </a:rPr>
-              <a:t>— ~1 drum/week to the 2nd source (~35% of total), unchanged.</a:t>
+              <a:t>— so a single 55-gal weekly batch is workable.</a:t>
             </a:r>
           </a:p>
         </p:txBody>
@@ -8551,7 +8457,7 @@
                 </a:solidFill>
                 <a:latin typeface="Calibri"/>
               </a:rPr>
-              <a:t>Weekly — 1 drum / wk</a:t>
+              <a:t>Weekly — 1 drum/wk  (RECOMMENDED)</a:t>
             </a:r>
           </a:p>
           <a:p>
@@ -8567,7 +8473,7 @@
                 </a:solidFill>
                 <a:latin typeface="Calibri"/>
               </a:rPr>
-              <a:t>•  Simplest, freshest</a:t>
+              <a:t>•  Matches the 1-drum/wk cap</a:t>
             </a:r>
           </a:p>
           <a:p>
@@ -8583,7 +8489,7 @@
                 </a:solidFill>
                 <a:latin typeface="Calibri"/>
               </a:rPr>
-              <a:t>•  Used well within shelf life</a:t>
+              <a:t>•  Freshest; well within shelf life</a:t>
             </a:r>
           </a:p>
           <a:p>
@@ -8599,7 +8505,7 @@
                 </a:solidFill>
                 <a:latin typeface="Calibri"/>
               </a:rPr>
-              <a:t>•  Small batch for APV → higher $/lb</a:t>
+              <a:t>•  APV does small batches → single drum OK</a:t>
             </a:r>
           </a:p>
         </p:txBody>
@@ -8682,7 +8588,7 @@
                 </a:solidFill>
                 <a:latin typeface="Calibri"/>
               </a:rPr>
-              <a:t>Biweekly — 2 drums / 2 wks  (RECOMMENDED)</a:t>
+              <a:t>Biweekly — 2 drums/2 wks  (optional)</a:t>
             </a:r>
           </a:p>
           <a:p>
@@ -8698,7 +8604,7 @@
                 </a:solidFill>
                 <a:latin typeface="Calibri"/>
               </a:rPr>
-              <a:t>•  110 gal hits APV's batch sweet spot → better price</a:t>
+              <a:t>•  Still ~1/wk average &amp; within shelf life</a:t>
             </a:r>
           </a:p>
           <a:p>
@@ -8714,7 +8620,7 @@
                 </a:solidFill>
                 <a:latin typeface="Calibri"/>
               </a:rPr>
-              <a:t>•  2 weeks supply &lt; 18-day shelf life → safe</a:t>
+              <a:t>•  Means holding 2 drums at once</a:t>
             </a:r>
           </a:p>
           <a:p>
@@ -8730,7 +8636,7 @@
                 </a:solidFill>
                 <a:latin typeface="Calibri"/>
               </a:rPr>
-              <a:t>•  Best balance of price + freshness</a:t>
+              <a:t>•  Marginally fewer setups — minor price help</a:t>
             </a:r>
           </a:p>
         </p:txBody>
@@ -8813,7 +8719,7 @@
                 </a:solidFill>
                 <a:latin typeface="Calibri"/>
               </a:rPr>
-              <a:t>3+ drums / batch — AVOID</a:t>
+              <a:t>3+ drums/batch — AVOID</a:t>
             </a:r>
           </a:p>
           <a:p>
@@ -8829,7 +8735,7 @@
                 </a:solidFill>
                 <a:latin typeface="Calibri"/>
               </a:rPr>
-              <a:t>•  3+ weeks supply &gt; 18-day shelf life</a:t>
+              <a:t>•  Exceeds the 1-drum/wk cap</a:t>
             </a:r>
           </a:p>
           <a:p>
@@ -8845,23 +8751,23 @@
                 </a:solidFill>
                 <a:latin typeface="Calibri"/>
               </a:rPr>
+              <a:t>•  3+ wks supply &gt; 18-day shelf life</a:t>
+            </a:r>
+          </a:p>
+          <a:p>
+            <a:pPr algn="l">
+              <a:spcAft>
+                <a:spcPts val="700"/>
+              </a:spcAft>
+            </a:pPr>
+            <a:r>
+              <a:rPr sz="1250" b="0" i="0">
+                <a:solidFill>
+                  <a:srgbClr val="595959"/>
+                </a:solidFill>
+                <a:latin typeface="Calibri"/>
+              </a:rPr>
               <a:t>•  Oldest drum ages out → waste / risk</a:t>
-            </a:r>
-          </a:p>
-          <a:p>
-            <a:pPr algn="l">
-              <a:spcAft>
-                <a:spcPts val="700"/>
-              </a:spcAft>
-            </a:pPr>
-            <a:r>
-              <a:rPr sz="1250" b="0" i="0">
-                <a:solidFill>
-                  <a:srgbClr val="595959"/>
-                </a:solidFill>
-                <a:latin typeface="Calibri"/>
-              </a:rPr>
-              <a:t>•  Don't let APV batch larger just to cut price</a:t>
             </a:r>
           </a:p>
         </p:txBody>
@@ -8900,7 +8806,7 @@
                 </a:solidFill>
                 <a:latin typeface="Calibri"/>
               </a:rPr>
-              <a:t>Rule of thumb: order at least every 2 weeks, max ~2 drums per batch. The biweekly 2-drum cadence gives APV an efficient batch (supports the lower price) while staying inside the 18-day shelf life.</a:t>
+              <a:t>Operating model: weekly single-drum delivery. The 1-drum/week cap rules out larger batches; APV's small-batch capability (from 5 gal) makes weekly drums workable, and the 18-day shelf life comfortably covers them.</a:t>
             </a:r>
           </a:p>
         </p:txBody>

</xml_diff>